<commit_message>
Sua slide & ban thuyet trinh: anh chu nhat, them da ngon ngu & lien thong
- Fix anh giao dien bi bo elip -> chu nhat (bo rounding:true trong build_pptx)
- Lam muot loi doc Slide 1
- Slide 6: bo sung chuyen muc Thu tuc lien thong trong diem
- Slide 7: them da ngon ngu Viet-Anh-Trung & che do Chu to
- Slide 8: them diem moi thu 4 "Da ngon ngu" (3 -> 4 the)
- Build lai Thuyet-trinh-Cong-Thong-Tin-So.pptx

Co-Authored-By: Claude Opus 4.8 <noreply@anthropic.com>
</commit_message>
<xml_diff>
--- a/Thuyet-trinh-Cong-Thong-Tin-So.pptx
+++ b/Thuyet-trinh-Cong-Thong-Tin-So.pptx
@@ -514,7 +514,7 @@
           <a:p>
             <a:r>
               <a:rPr lang="en-US" dirty="0"/>
-              <a:t>Kính thưa các đồng chí trong Hội đồng. Tôi xin trình bày sáng kiến Cổng thông tin số và Trợ lý ảo hỗ trợ tra cứu thủ tục hành chính tại Công an phường Phú Thọ. Đây là một giải pháp chuyển đổi số xuất phát trực tiếp từ công tác tiếp dân hằng ngày: người dân chỉ cần quét một mã QR, không phải cài đặt gì, là có ngay một trợ lý hướng dẫn thủ tục 24/7. Sáng kiến do cán bộ đơn vị tự nghiên cứu, lập trình, chi phí gần như bằng không, trên mảnh đất cội nguồn Đất Tổ Hùng Vương.</a:t>
+              <a:t>Kính thưa các đồng chí trong Hội đồng. Tôi xin trình bày sáng kiến Cổng thông tin số và Trợ lý ảo hỗ trợ tra cứu thủ tục hành chính tại Công an phường Phú Thọ. Đây là giải pháp chuyển đổi số xuất phát trực tiếp từ thực tiễn công tác tiếp dân hằng ngày: người dân chỉ cần quét một mã QR, không cần cài đặt bất kỳ ứng dụng nào, là đã có ngay một trợ lý hướng dẫn thủ tục phục vụ 24/7. Toàn bộ sáng kiến do cán bộ đơn vị tự nghiên cứu và lập trình, chi phí gần như bằng không, một sản phẩm công nghệ của người Công an cơ sở, ngay trên quê hương Đất Tổ Hùng Vương.</a:t>
             </a:r>
             <a:endParaRPr lang="en-US" dirty="0"/>
           </a:p>
@@ -1306,7 +1306,7 @@
           <a:p>
             <a:r>
               <a:rPr lang="en-US" dirty="0"/>
-              <a:t>Cổng phân loại thủ tục thành 06 nhóm lĩnh vực trọng tâm cấp phường: cư trú và căn cước; đăng ký xe máy; quản lý ngành nghề an ninh trật tự; quản lý người nước ngoài; vũ khí và pháo; cùng khiếu nại, tố cáo và góp ý. Mỗi lĩnh vực trình bày dạng thẻ gập mở, tóm tắt cực ngắn gọn ba điều người dân cần nhất: cần giấy tờ gì, mất bao lâu, và có nút liên kết nộp hồ sơ online ngay trên Cổng dịch vụ công Bộ Công an.</a:t>
+              <a:t>Cổng phân loại thủ tục thành 06 nhóm lĩnh vực trọng tâm cấp phường: cư trú và căn cước; đăng ký xe máy; quản lý ngành nghề an ninh trật tự; quản lý người nước ngoài; vũ khí và pháo; cùng khiếu nại, tố cáo và góp ý. Mỗi lĩnh vực trình bày dạng thẻ gập mở, tóm tắt cực ngắn gọn ba điều người dân cần nhất: cần giấy tờ gì, mất bao lâu, và có nút liên kết nộp hồ sơ online ngay trên Cổng dịch vụ công Bộ Công an. Ngoài 06 nhóm này, Cổng còn dành riêng một chuyên mục Thủ tục liên thông trọng điểm, như khai sinh, đăng ký thường trú, cấp thẻ bảo hiểm y tế cho trẻ dưới 6 tuổi, hay khai tử, xóa thường trú, vốn là những việc người dân hay vướng mắc nhất.</a:t>
             </a:r>
             <a:endParaRPr lang="en-US" dirty="0"/>
           </a:p>
@@ -1394,7 +1394,7 @@
           <a:p>
             <a:r>
               <a:rPr lang="en-US" dirty="0"/>
-              <a:t>Đây là giao diện thật của cổng, chụp trực tiếp trên điện thoại. Thiết kế theo phong cách Cổng dịch vụ công, tối ưu 100% cho điện thoại, nút bấm lớn, icon trực quan, màu đỏ vàng nhận diện của lực lượng. Từ trang chủ với các thẻ dịch vụ, đến trợ lý ảo hỏi đáp, trang hướng dẫn từng lĩnh vực, tất cả gọn trong lòng bàn tay.</a:t>
+              <a:t>Đây là giao diện thật của Cổng, chụp trực tiếp trên điện thoại. Thiết kế theo phong cách Cổng dịch vụ công, tối ưu 100% cho điện thoại, nút bấm lớn, icon trực quan, màu đỏ vàng nhận diện của lực lượng. Ngay trên đầu trang có nút đổi ngôn ngữ Việt, Anh, Trung và chế độ Chữ to dễ đọc cho người cao tuổi. Từ trang chủ với các thẻ dịch vụ, đến trợ lý ảo hỏi đáp, trang hướng dẫn từng lĩnh vực, tất cả gọn trong lòng bàn tay.</a:t>
             </a:r>
             <a:endParaRPr lang="en-US" dirty="0"/>
           </a:p>
@@ -1482,7 +1482,7 @@
           <a:p>
             <a:r>
               <a:rPr lang="en-US" dirty="0"/>
-              <a:t>Điểm mới nằm ở ba chỗ. Thứ nhất, thay vì bắt dân đọc cả văn bản luật dài, cổng đã bình dân hóa ngôn ngữ pháp lý thành những gạch đầu dòng ngắn gọn, dễ hiểu. Thứ hai là Trợ lý ảo Chatbot: người dân chỉ cần gõ từ khóa như làm sổ tạm trú hay mất cà vẹt xe, hệ thống tự quét dữ liệu và trả lời chính xác, không cần con người can thiệp. Thứ ba, nhờ tư duy web tĩnh, trang tải cực nhanh, chi phí vận hành gần bằng 0 và đóng gói chuyển giao cho đơn vị khác rất dễ.</a:t>
+              <a:t>Điểm mới nằm ở bốn chỗ. Thứ nhất, thay vì bắt dân đọc cả văn bản luật dài, Cổng đã bình dân hóa ngôn ngữ pháp lý thành những gạch đầu dòng ngắn gọn, dễ hiểu. Thứ hai là Trợ lý ảo Chatbot: người dân chỉ cần gõ từ khóa như làm sổ tạm trú hay mất cà vẹt xe, hệ thống tự quét dữ liệu và trả lời chính xác, không cần con người can thiệp. Thứ ba, Cổng hỗ trợ ba thứ tiếng Việt, Anh, Trung cùng chế độ Chữ to dễ đọc, phục vụ cả người nước ngoài lẫn người cao tuổi tự tra cứu. Thứ tư, nhờ tư duy web tĩnh, trang tải cực nhanh, chi phí vận hành gần bằng 0 và đóng gói chuyển giao cho đơn vị khác rất dễ.</a:t>
             </a:r>
             <a:endParaRPr lang="en-US" dirty="0"/>
           </a:p>
@@ -1991,7 +1991,7 @@
       </p:pic>
       <p:pic>
         <p:nvPicPr>
-          <p:cNvPr id="4" name="Image 1" descr="/home/user/capphutho/logo.png">    </p:cNvPr>
+          <p:cNvPr id="4" name="Image 1" descr="D:\04. Github\capphutho\logo.png">    </p:cNvPr>
           <p:cNvPicPr>
             <a:picLocks noChangeAspect="1"/>
           </p:cNvPicPr>
@@ -9559,7 +9559,7 @@
                 <a:ea typeface="Segoe UI" pitchFamily="34" charset="-122"/>
                 <a:cs typeface="Segoe UI" pitchFamily="34" charset="-120"/>
               </a:rPr>
-              <a:t>Mỗi lĩnh vực là một thẻ gập/mở: cần giấy tờ gì · thời gian bao lâu · nút nộp online.</a:t>
+              <a:t>Mỗi lĩnh vực là một thẻ gập/mở (giấy tờ · thời gian · nút nộp online) — kèm chuyên mục riêng “Thủ tục liên thông trọng điểm”.</a:t>
             </a:r>
             <a:endParaRPr lang="en-US" sz="1400" dirty="0"/>
           </a:p>
@@ -11185,7 +11185,7 @@
       </p:sp>
       <p:pic>
         <p:nvPicPr>
-          <p:cNvPr id="6" name="Image 0" descr="/home/user/capphutho/shots/home.png">    </p:cNvPr>
+          <p:cNvPr id="6" name="Image 0" descr="D:\04. Github\capphutho\shots\home.png">    </p:cNvPr>
           <p:cNvPicPr>
             <a:picLocks noChangeAspect="1"/>
           </p:cNvPicPr>
@@ -11201,7 +11201,7 @@
             <a:off x="1697126" y="1920240"/>
             <a:ext cx="1814627" cy="3703320"/>
           </a:xfrm>
-          <a:prstGeom prst="ellipse">
+          <a:prstGeom prst="rect">
             <a:avLst/>
           </a:prstGeom>
         </p:spPr>
@@ -11276,7 +11276,7 @@
       </p:sp>
       <p:pic>
         <p:nvPicPr>
-          <p:cNvPr id="9" name="Image 1" descr="/home/user/capphutho/shots/chatbot.png">    </p:cNvPr>
+          <p:cNvPr id="9" name="Image 1" descr="D:\04. Github\capphutho\shots\chatbot.png">    </p:cNvPr>
           <p:cNvPicPr>
             <a:picLocks noChangeAspect="1"/>
           </p:cNvPicPr>
@@ -11292,7 +11292,7 @@
             <a:off x="4014673" y="1920240"/>
             <a:ext cx="1814627" cy="3703320"/>
           </a:xfrm>
-          <a:prstGeom prst="ellipse">
+          <a:prstGeom prst="rect">
             <a:avLst/>
           </a:prstGeom>
         </p:spPr>
@@ -11367,7 +11367,7 @@
       </p:sp>
       <p:pic>
         <p:nvPicPr>
-          <p:cNvPr id="12" name="Image 2" descr="/home/user/capphutho/shots/modules.png">    </p:cNvPr>
+          <p:cNvPr id="12" name="Image 2" descr="D:\04. Github\capphutho\shots\modules.png">    </p:cNvPr>
           <p:cNvPicPr>
             <a:picLocks noChangeAspect="1"/>
           </p:cNvPicPr>
@@ -11383,7 +11383,7 @@
             <a:off x="6332220" y="1920240"/>
             <a:ext cx="1814627" cy="3703320"/>
           </a:xfrm>
-          <a:prstGeom prst="ellipse">
+          <a:prstGeom prst="rect">
             <a:avLst/>
           </a:prstGeom>
         </p:spPr>
@@ -11458,7 +11458,7 @@
       </p:sp>
       <p:pic>
         <p:nvPicPr>
-          <p:cNvPr id="15" name="Image 3" descr="/home/user/capphutho/shots/lienthong.png">    </p:cNvPr>
+          <p:cNvPr id="15" name="Image 3" descr="D:\04. Github\capphutho\shots\lienthong.png">    </p:cNvPr>
           <p:cNvPicPr>
             <a:picLocks noChangeAspect="1"/>
           </p:cNvPicPr>
@@ -11474,7 +11474,7 @@
             <a:off x="8649767" y="1920240"/>
             <a:ext cx="1814627" cy="3703320"/>
           </a:xfrm>
-          <a:prstGeom prst="ellipse">
+          <a:prstGeom prst="rect">
             <a:avLst/>
           </a:prstGeom>
         </p:spPr>
@@ -11749,7 +11749,7 @@
                 <a:ea typeface="Segoe UI" pitchFamily="34" charset="-122"/>
                 <a:cs typeface="Segoe UI" pitchFamily="34" charset="-120"/>
               </a:rPr>
-              <a:t>Ba điểm khác biệt cốt lõi</a:t>
+              <a:t>Bốn điểm khác biệt cốt lõi</a:t>
             </a:r>
             <a:endParaRPr lang="en-US" sz="2800" dirty="0"/>
           </a:p>
@@ -11784,11 +11784,11 @@
         <p:spPr>
           <a:xfrm>
             <a:off x="640080" y="2194560"/>
-            <a:ext cx="3322320" cy="3108960"/>
+            <a:ext cx="2377440" cy="3108960"/>
           </a:xfrm>
           <a:prstGeom prst="roundRect">
             <a:avLst>
-              <a:gd name="adj" fmla="val 3529"/>
+              <a:gd name="adj" fmla="val 4615"/>
             </a:avLst>
           </a:prstGeom>
           <a:solidFill>
@@ -11817,7 +11817,7 @@
         </p:nvSpPr>
         <p:spPr>
           <a:xfrm>
-            <a:off x="1752600" y="2542032"/>
+            <a:off x="1280160" y="2542032"/>
             <a:ext cx="1097280" cy="1097280"/>
           </a:xfrm>
           <a:prstGeom prst="ellipse">
@@ -11852,7 +11852,7 @@
         </p:blipFill>
         <p:spPr>
           <a:xfrm>
-            <a:off x="2048866" y="2838298"/>
+            <a:off x="1576426" y="2838298"/>
             <a:ext cx="504749" cy="504749"/>
           </a:xfrm>
           <a:prstGeom prst="rect">
@@ -11869,7 +11869,7 @@
         <p:spPr>
           <a:xfrm>
             <a:off x="822960" y="3794760"/>
-            <a:ext cx="2956560" cy="548640"/>
+            <a:ext cx="2011680" cy="548640"/>
           </a:xfrm>
           <a:prstGeom prst="rect">
             <a:avLst/>
@@ -11908,7 +11908,7 @@
         <p:spPr>
           <a:xfrm>
             <a:off x="914400" y="4389120"/>
-            <a:ext cx="2773680" cy="868680"/>
+            <a:ext cx="1828800" cy="868680"/>
           </a:xfrm>
           <a:prstGeom prst="rect">
             <a:avLst/>
@@ -11946,12 +11946,12 @@
         </p:nvSpPr>
         <p:spPr>
           <a:xfrm>
-            <a:off x="4419600" y="2194560"/>
-            <a:ext cx="3322320" cy="3108960"/>
+            <a:off x="3474720" y="2194560"/>
+            <a:ext cx="2377440" cy="3108960"/>
           </a:xfrm>
           <a:prstGeom prst="roundRect">
             <a:avLst>
-              <a:gd name="adj" fmla="val 3529"/>
+              <a:gd name="adj" fmla="val 4615"/>
             </a:avLst>
           </a:prstGeom>
           <a:solidFill>
@@ -11980,7 +11980,7 @@
         </p:nvSpPr>
         <p:spPr>
           <a:xfrm>
-            <a:off x="5532120" y="2542032"/>
+            <a:off x="4114800" y="2542032"/>
             <a:ext cx="1097280" cy="1097280"/>
           </a:xfrm>
           <a:prstGeom prst="ellipse">
@@ -12015,7 +12015,7 @@
         </p:blipFill>
         <p:spPr>
           <a:xfrm>
-            <a:off x="5828386" y="2838298"/>
+            <a:off x="4411066" y="2838298"/>
             <a:ext cx="504749" cy="504749"/>
           </a:xfrm>
           <a:prstGeom prst="rect">
@@ -12031,8 +12031,8 @@
         </p:nvSpPr>
         <p:spPr>
           <a:xfrm>
-            <a:off x="4602480" y="3794760"/>
-            <a:ext cx="2956560" cy="548640"/>
+            <a:off x="3657600" y="3794760"/>
+            <a:ext cx="2011680" cy="548640"/>
           </a:xfrm>
           <a:prstGeom prst="rect">
             <a:avLst/>
@@ -12070,8 +12070,8 @@
         </p:nvSpPr>
         <p:spPr>
           <a:xfrm>
-            <a:off x="4693920" y="4389120"/>
-            <a:ext cx="2773680" cy="868680"/>
+            <a:off x="3749040" y="4389120"/>
+            <a:ext cx="1828800" cy="868680"/>
           </a:xfrm>
           <a:prstGeom prst="rect">
             <a:avLst/>
@@ -12109,12 +12109,12 @@
         </p:nvSpPr>
         <p:spPr>
           <a:xfrm>
-            <a:off x="8199120" y="2194560"/>
-            <a:ext cx="3322320" cy="3108960"/>
+            <a:off x="6309360" y="2194560"/>
+            <a:ext cx="2377440" cy="3108960"/>
           </a:xfrm>
           <a:prstGeom prst="roundRect">
             <a:avLst>
-              <a:gd name="adj" fmla="val 3529"/>
+              <a:gd name="adj" fmla="val 4615"/>
             </a:avLst>
           </a:prstGeom>
           <a:solidFill>
@@ -12143,7 +12143,7 @@
         </p:nvSpPr>
         <p:spPr>
           <a:xfrm>
-            <a:off x="9311640" y="2542032"/>
+            <a:off x="6949440" y="2542032"/>
             <a:ext cx="1097280" cy="1097280"/>
           </a:xfrm>
           <a:prstGeom prst="ellipse">
@@ -12178,7 +12178,7 @@
         </p:blipFill>
         <p:spPr>
           <a:xfrm>
-            <a:off x="9607906" y="2838298"/>
+            <a:off x="7245706" y="2838298"/>
             <a:ext cx="504749" cy="504749"/>
           </a:xfrm>
           <a:prstGeom prst="rect">
@@ -12194,8 +12194,8 @@
         </p:nvSpPr>
         <p:spPr>
           <a:xfrm>
-            <a:off x="8382000" y="3794760"/>
-            <a:ext cx="2956560" cy="548640"/>
+            <a:off x="6492240" y="3794760"/>
+            <a:ext cx="2011680" cy="548640"/>
           </a:xfrm>
           <a:prstGeom prst="rect">
             <a:avLst/>
@@ -12219,7 +12219,7 @@
                 <a:ea typeface="Segoe UI" pitchFamily="34" charset="-122"/>
                 <a:cs typeface="Segoe UI" pitchFamily="34" charset="-120"/>
               </a:rPr>
-              <a:t>Web tĩnh siêu nhẹ</a:t>
+              <a:t>Đa ngôn ngữ</a:t>
             </a:r>
             <a:endParaRPr lang="en-US" sz="2100" dirty="0"/>
           </a:p>
@@ -12233,8 +12233,8 @@
         </p:nvSpPr>
         <p:spPr>
           <a:xfrm>
-            <a:off x="8473440" y="4389120"/>
-            <a:ext cx="2773680" cy="868680"/>
+            <a:off x="6583680" y="4389120"/>
+            <a:ext cx="1828800" cy="868680"/>
           </a:xfrm>
           <a:prstGeom prst="rect">
             <a:avLst/>
@@ -12258,22 +12258,185 @@
                 <a:ea typeface="Segoe UI" pitchFamily="34" charset="-122"/>
                 <a:cs typeface="Segoe UI" pitchFamily="34" charset="-120"/>
               </a:rPr>
-              <a:t>Tải cực nhanh · chi phí vận hành gần 0 · dễ đóng gói chuyển giao.</a:t>
+              <a:t>Giao diện Việt – Anh – Trung; có chế độ Chữ to cho người cao tuổi, người nước ngoài.</a:t>
             </a:r>
             <a:endParaRPr lang="en-US" sz="1400" dirty="0"/>
           </a:p>
         </p:txBody>
+      </p:sp>
+      <p:sp>
+        <p:nvSpPr>
+          <p:cNvPr id="20" name="Shape 15"/>
+          <p:cNvSpPr/>
+          <p:nvPr/>
+        </p:nvSpPr>
+        <p:spPr>
+          <a:xfrm>
+            <a:off x="9144000" y="2194560"/>
+            <a:ext cx="2377440" cy="3108960"/>
+          </a:xfrm>
+          <a:prstGeom prst="roundRect">
+            <a:avLst>
+              <a:gd name="adj" fmla="val 4615"/>
+            </a:avLst>
+          </a:prstGeom>
+          <a:solidFill>
+            <a:srgbClr val="FFF4F2"/>
+          </a:solidFill>
+          <a:ln w="12700">
+            <a:solidFill>
+              <a:srgbClr val="F3D2D7"/>
+            </a:solidFill>
+            <a:prstDash val="solid"/>
+          </a:ln>
+          <a:effectLst>
+            <a:outerShdw sx="100000" sy="100000" kx="0" ky="0" algn="bl" rotWithShape="0" blurRad="88900" dist="25400" dir="8100000">
+              <a:srgbClr val="94A3B8">
+                <a:alpha val="30000"/>
+              </a:srgbClr>
+            </a:outerShdw>
+          </a:effectLst>
+        </p:spPr>
+      </p:sp>
+      <p:sp>
+        <p:nvSpPr>
+          <p:cNvPr id="21" name="Shape 16"/>
+          <p:cNvSpPr/>
+          <p:nvPr/>
+        </p:nvSpPr>
+        <p:spPr>
+          <a:xfrm>
+            <a:off x="9784080" y="2542032"/>
+            <a:ext cx="1097280" cy="1097280"/>
+          </a:xfrm>
+          <a:prstGeom prst="ellipse">
+            <a:avLst/>
+          </a:prstGeom>
+          <a:solidFill>
+            <a:srgbClr val="8B0000"/>
+          </a:solidFill>
+          <a:ln/>
+          <a:effectLst>
+            <a:outerShdw sx="100000" sy="100000" kx="0" ky="0" algn="bl" rotWithShape="0" blurRad="114300" dist="38100" dir="8100000">
+              <a:srgbClr val="4E0008">
+                <a:alpha val="22000"/>
+              </a:srgbClr>
+            </a:outerShdw>
+          </a:effectLst>
+        </p:spPr>
       </p:sp>
       <p:pic>
         <p:nvPicPr>
-          <p:cNvPr id="20" name="Image 3" descr="preencoded.png">    </p:cNvPr>
+          <p:cNvPr id="22" name="Image 3" descr="preencoded.png">    </p:cNvPr>
           <p:cNvPicPr>
             <a:picLocks noChangeAspect="1"/>
           </p:cNvPicPr>
           <p:nvPr/>
         </p:nvPicPr>
         <p:blipFill>
-          <a:blip r:embed="rId4">
+          <a:blip r:embed="rId4"/>
+          <a:stretch>
+            <a:fillRect/>
+          </a:stretch>
+        </p:blipFill>
+        <p:spPr>
+          <a:xfrm>
+            <a:off x="10080346" y="2838298"/>
+            <a:ext cx="504749" cy="504749"/>
+          </a:xfrm>
+          <a:prstGeom prst="rect">
+            <a:avLst/>
+          </a:prstGeom>
+        </p:spPr>
+      </p:pic>
+      <p:sp>
+        <p:nvSpPr>
+          <p:cNvPr id="23" name="Text 17"/>
+          <p:cNvSpPr/>
+          <p:nvPr/>
+        </p:nvSpPr>
+        <p:spPr>
+          <a:xfrm>
+            <a:off x="9326880" y="3794760"/>
+            <a:ext cx="2011680" cy="548640"/>
+          </a:xfrm>
+          <a:prstGeom prst="rect">
+            <a:avLst/>
+          </a:prstGeom>
+          <a:noFill/>
+          <a:ln/>
+        </p:spPr>
+        <p:txBody>
+          <a:bodyPr wrap="square" lIns="0" tIns="0" rIns="0" bIns="0" rtlCol="0" anchor="ctr"/>
+          <a:lstStyle/>
+          <a:p>
+            <a:pPr algn="ctr" indent="0" marL="0">
+              <a:buNone/>
+            </a:pPr>
+            <a:r>
+              <a:rPr lang="en-US" sz="2100" b="1" dirty="0">
+                <a:solidFill>
+                  <a:srgbClr val="1F2937"/>
+                </a:solidFill>
+                <a:latin typeface="Segoe UI" pitchFamily="34" charset="0"/>
+                <a:ea typeface="Segoe UI" pitchFamily="34" charset="-122"/>
+                <a:cs typeface="Segoe UI" pitchFamily="34" charset="-120"/>
+              </a:rPr>
+              <a:t>Web tĩnh siêu nhẹ</a:t>
+            </a:r>
+            <a:endParaRPr lang="en-US" sz="2100" dirty="0"/>
+          </a:p>
+        </p:txBody>
+      </p:sp>
+      <p:sp>
+        <p:nvSpPr>
+          <p:cNvPr id="24" name="Text 18"/>
+          <p:cNvSpPr/>
+          <p:nvPr/>
+        </p:nvSpPr>
+        <p:spPr>
+          <a:xfrm>
+            <a:off x="9418320" y="4389120"/>
+            <a:ext cx="1828800" cy="868680"/>
+          </a:xfrm>
+          <a:prstGeom prst="rect">
+            <a:avLst/>
+          </a:prstGeom>
+          <a:noFill/>
+          <a:ln/>
+        </p:spPr>
+        <p:txBody>
+          <a:bodyPr wrap="square" lIns="0" tIns="0" rIns="0" bIns="0" rtlCol="0" anchor="ctr"/>
+          <a:lstStyle/>
+          <a:p>
+            <a:pPr algn="ctr" indent="0" marL="0">
+              <a:buNone/>
+            </a:pPr>
+            <a:r>
+              <a:rPr lang="en-US" sz="1400" dirty="0">
+                <a:solidFill>
+                  <a:srgbClr val="374151"/>
+                </a:solidFill>
+                <a:latin typeface="Segoe UI" pitchFamily="34" charset="0"/>
+                <a:ea typeface="Segoe UI" pitchFamily="34" charset="-122"/>
+                <a:cs typeface="Segoe UI" pitchFamily="34" charset="-120"/>
+              </a:rPr>
+              <a:t>Tải cực nhanh · chi phí vận hành gần 0 · dễ đóng gói chuyển giao.</a:t>
+            </a:r>
+            <a:endParaRPr lang="en-US" sz="1400" dirty="0"/>
+          </a:p>
+        </p:txBody>
+      </p:sp>
+      <p:pic>
+        <p:nvPicPr>
+          <p:cNvPr id="25" name="Image 4" descr="preencoded.png">    </p:cNvPr>
+          <p:cNvPicPr>
+            <a:picLocks noChangeAspect="1"/>
+          </p:cNvPicPr>
+          <p:nvPr/>
+        </p:nvPicPr>
+        <p:blipFill>
+          <a:blip r:embed="rId5">
             <a:alphaModFix amt="70000"/>
           </a:blip>
           <a:stretch>
@@ -12292,7 +12455,7 @@
       </p:pic>
       <p:sp>
         <p:nvSpPr>
-          <p:cNvPr id="21" name="Shape 15"/>
+          <p:cNvPr id="26" name="Shape 19"/>
           <p:cNvSpPr/>
           <p:nvPr/>
         </p:nvSpPr>
@@ -12312,7 +12475,7 @@
       </p:sp>
       <p:sp>
         <p:nvSpPr>
-          <p:cNvPr id="22" name="Text 16"/>
+          <p:cNvPr id="27" name="Text 20"/>
           <p:cNvSpPr/>
           <p:nvPr/>
         </p:nvSpPr>
@@ -12351,7 +12514,7 @@
       </p:sp>
       <p:sp>
         <p:nvSpPr>
-          <p:cNvPr id="23" name="Text 17"/>
+          <p:cNvPr id="28" name="Text 21"/>
           <p:cNvSpPr/>
           <p:nvPr/>
         </p:nvSpPr>

</xml_diff>